<commit_message>
Pitch deck PPTX: fix slide 5 stat wrap, slide 15 doubled text
- Slide 5: split big '94%' into adjacent text boxes so the percent symbol
  no longer wraps onto the smaller stats below; reduced size from 200pt to 160pt
- Slide 15: replaced the rendered closer-sphere image (which carried the
  PDF text inside it) with native PowerPoint concentric-oval shapes,
  eliminating the doubled 'Read the geometry / Read the future' overlay

Co-Authored-By: Claude Opus 4.7 (1M context) <noreply@anthropic.com>
</commit_message>
<xml_diff>
--- a/pitch/GhostLine_Pitch_Deck.pptx
+++ b/pitch/GhostLine_Pitch_Deck.pptx
@@ -7478,33 +7478,224 @@
           </a:p>
         </p:txBody>
       </p:sp>
-      <p:pic>
-        <p:nvPicPr>
-          <p:cNvPr id="3" name="Picture 2" descr="closer_sphere.png"/>
-          <p:cNvPicPr>
-            <a:picLocks noChangeAspect="1"/>
-          </p:cNvPicPr>
-          <p:nvPr/>
-        </p:nvPicPr>
-        <p:blipFill>
-          <a:blip r:embed="rId2"/>
-          <a:stretch>
-            <a:fillRect/>
-          </a:stretch>
-        </p:blipFill>
-        <p:spPr>
-          <a:xfrm>
-            <a:off x="0" y="0"/>
-            <a:ext cx="12191695" cy="6858000"/>
-          </a:xfrm>
-          <a:prstGeom prst="rect">
-            <a:avLst/>
-          </a:prstGeom>
-        </p:spPr>
-      </p:pic>
-      <p:sp>
-        <p:nvSpPr>
-          <p:cNvPr id="4" name="TextBox 3"/>
+      <p:sp>
+        <p:nvSpPr>
+          <p:cNvPr id="3" name="Oval 2"/>
+          <p:cNvSpPr/>
+          <p:nvPr/>
+        </p:nvSpPr>
+        <p:spPr>
+          <a:xfrm>
+            <a:off x="4633264" y="1965960"/>
+            <a:ext cx="2926080" cy="2926080"/>
+          </a:xfrm>
+          <a:prstGeom prst="ellipse">
+            <a:avLst/>
+          </a:prstGeom>
+          <a:noFill/>
+          <a:ln w="9525">
+            <a:solidFill>
+              <a:srgbClr val="164A33"/>
+            </a:solidFill>
+          </a:ln>
+        </p:spPr>
+        <p:style>
+          <a:lnRef idx="1">
+            <a:schemeClr val="accent1"/>
+          </a:lnRef>
+          <a:fillRef idx="3">
+            <a:schemeClr val="accent1"/>
+          </a:fillRef>
+          <a:effectRef idx="2">
+            <a:schemeClr val="accent1"/>
+          </a:effectRef>
+          <a:fontRef idx="minor">
+            <a:schemeClr val="lt1"/>
+          </a:fontRef>
+        </p:style>
+        <p:txBody>
+          <a:bodyPr rtlCol="0" anchor="ctr"/>
+          <a:lstStyle/>
+          <a:p>
+            <a:pPr algn="ctr"/>
+          </a:p>
+        </p:txBody>
+      </p:sp>
+      <p:sp>
+        <p:nvSpPr>
+          <p:cNvPr id="4" name="Oval 3"/>
+          <p:cNvSpPr/>
+          <p:nvPr/>
+        </p:nvSpPr>
+        <p:spPr>
+          <a:xfrm>
+            <a:off x="3901744" y="1234440"/>
+            <a:ext cx="4389120" cy="4389120"/>
+          </a:xfrm>
+          <a:prstGeom prst="ellipse">
+            <a:avLst/>
+          </a:prstGeom>
+          <a:noFill/>
+          <a:ln w="9525">
+            <a:solidFill>
+              <a:srgbClr val="164A33"/>
+            </a:solidFill>
+          </a:ln>
+        </p:spPr>
+        <p:style>
+          <a:lnRef idx="1">
+            <a:schemeClr val="accent1"/>
+          </a:lnRef>
+          <a:fillRef idx="3">
+            <a:schemeClr val="accent1"/>
+          </a:fillRef>
+          <a:effectRef idx="2">
+            <a:schemeClr val="accent1"/>
+          </a:effectRef>
+          <a:fontRef idx="minor">
+            <a:schemeClr val="lt1"/>
+          </a:fontRef>
+        </p:style>
+        <p:txBody>
+          <a:bodyPr rtlCol="0" anchor="ctr"/>
+          <a:lstStyle/>
+          <a:p>
+            <a:pPr algn="ctr"/>
+          </a:p>
+        </p:txBody>
+      </p:sp>
+      <p:sp>
+        <p:nvSpPr>
+          <p:cNvPr id="5" name="Oval 4"/>
+          <p:cNvSpPr/>
+          <p:nvPr/>
+        </p:nvSpPr>
+        <p:spPr>
+          <a:xfrm>
+            <a:off x="3170224" y="502920"/>
+            <a:ext cx="5852160" cy="5852160"/>
+          </a:xfrm>
+          <a:prstGeom prst="ellipse">
+            <a:avLst/>
+          </a:prstGeom>
+          <a:noFill/>
+          <a:ln w="9525">
+            <a:solidFill>
+              <a:srgbClr val="164A33"/>
+            </a:solidFill>
+          </a:ln>
+        </p:spPr>
+        <p:style>
+          <a:lnRef idx="1">
+            <a:schemeClr val="accent1"/>
+          </a:lnRef>
+          <a:fillRef idx="3">
+            <a:schemeClr val="accent1"/>
+          </a:fillRef>
+          <a:effectRef idx="2">
+            <a:schemeClr val="accent1"/>
+          </a:effectRef>
+          <a:fontRef idx="minor">
+            <a:schemeClr val="lt1"/>
+          </a:fontRef>
+        </p:style>
+        <p:txBody>
+          <a:bodyPr rtlCol="0" anchor="ctr"/>
+          <a:lstStyle/>
+          <a:p>
+            <a:pPr algn="ctr"/>
+          </a:p>
+        </p:txBody>
+      </p:sp>
+      <p:sp>
+        <p:nvSpPr>
+          <p:cNvPr id="6" name="Oval 5"/>
+          <p:cNvSpPr/>
+          <p:nvPr/>
+        </p:nvSpPr>
+        <p:spPr>
+          <a:xfrm>
+            <a:off x="2438704" y="-228600"/>
+            <a:ext cx="7315200" cy="7315200"/>
+          </a:xfrm>
+          <a:prstGeom prst="ellipse">
+            <a:avLst/>
+          </a:prstGeom>
+          <a:noFill/>
+          <a:ln w="9525">
+            <a:solidFill>
+              <a:srgbClr val="164A33"/>
+            </a:solidFill>
+          </a:ln>
+        </p:spPr>
+        <p:style>
+          <a:lnRef idx="1">
+            <a:schemeClr val="accent1"/>
+          </a:lnRef>
+          <a:fillRef idx="3">
+            <a:schemeClr val="accent1"/>
+          </a:fillRef>
+          <a:effectRef idx="2">
+            <a:schemeClr val="accent1"/>
+          </a:effectRef>
+          <a:fontRef idx="minor">
+            <a:schemeClr val="lt1"/>
+          </a:fontRef>
+        </p:style>
+        <p:txBody>
+          <a:bodyPr rtlCol="0" anchor="ctr"/>
+          <a:lstStyle/>
+          <a:p>
+            <a:pPr algn="ctr"/>
+          </a:p>
+        </p:txBody>
+      </p:sp>
+      <p:sp>
+        <p:nvSpPr>
+          <p:cNvPr id="7" name="Oval 6"/>
+          <p:cNvSpPr/>
+          <p:nvPr/>
+        </p:nvSpPr>
+        <p:spPr>
+          <a:xfrm>
+            <a:off x="1707184" y="-960120"/>
+            <a:ext cx="8778240" cy="8778240"/>
+          </a:xfrm>
+          <a:prstGeom prst="ellipse">
+            <a:avLst/>
+          </a:prstGeom>
+          <a:noFill/>
+          <a:ln w="9525">
+            <a:solidFill>
+              <a:srgbClr val="164A33"/>
+            </a:solidFill>
+          </a:ln>
+        </p:spPr>
+        <p:style>
+          <a:lnRef idx="1">
+            <a:schemeClr val="accent1"/>
+          </a:lnRef>
+          <a:fillRef idx="3">
+            <a:schemeClr val="accent1"/>
+          </a:fillRef>
+          <a:effectRef idx="2">
+            <a:schemeClr val="accent1"/>
+          </a:effectRef>
+          <a:fontRef idx="minor">
+            <a:schemeClr val="lt1"/>
+          </a:fontRef>
+        </p:style>
+        <p:txBody>
+          <a:bodyPr rtlCol="0" anchor="ctr"/>
+          <a:lstStyle/>
+          <a:p>
+            <a:pPr algn="ctr"/>
+          </a:p>
+        </p:txBody>
+      </p:sp>
+      <p:sp>
+        <p:nvSpPr>
+          <p:cNvPr id="8" name="TextBox 7"/>
           <p:cNvSpPr txBox="1"/>
           <p:nvPr/>
         </p:nvSpPr>
@@ -7539,7 +7730,7 @@
       </p:sp>
       <p:sp>
         <p:nvSpPr>
-          <p:cNvPr id="5" name="TextBox 4"/>
+          <p:cNvPr id="9" name="TextBox 8"/>
           <p:cNvSpPr txBox="1"/>
           <p:nvPr/>
         </p:nvSpPr>
@@ -7574,7 +7765,7 @@
       </p:sp>
       <p:sp>
         <p:nvSpPr>
-          <p:cNvPr id="6" name="TextBox 5"/>
+          <p:cNvPr id="10" name="TextBox 9"/>
           <p:cNvSpPr txBox="1"/>
           <p:nvPr/>
         </p:nvSpPr>
@@ -7609,7 +7800,7 @@
       </p:sp>
       <p:sp>
         <p:nvSpPr>
-          <p:cNvPr id="7" name="TextBox 6"/>
+          <p:cNvPr id="11" name="TextBox 10"/>
           <p:cNvSpPr txBox="1"/>
           <p:nvPr/>
         </p:nvSpPr>
@@ -7644,7 +7835,7 @@
       </p:sp>
       <p:sp>
         <p:nvSpPr>
-          <p:cNvPr id="8" name="TextBox 7"/>
+          <p:cNvPr id="12" name="TextBox 11"/>
           <p:cNvSpPr txBox="1"/>
           <p:nvPr/>
         </p:nvSpPr>
@@ -7715,7 +7906,7 @@
       </p:sp>
       <p:sp>
         <p:nvSpPr>
-          <p:cNvPr id="9" name="TextBox 8"/>
+          <p:cNvPr id="13" name="TextBox 12"/>
           <p:cNvSpPr txBox="1"/>
           <p:nvPr/>
         </p:nvSpPr>
@@ -9731,23 +9922,23 @@
         </p:nvSpPr>
         <p:spPr>
           <a:xfrm>
-            <a:off x="6858000" y="914400"/>
-            <a:ext cx="4846320" cy="2377440"/>
-          </a:xfrm>
-          <a:prstGeom prst="rect">
-            <a:avLst/>
-          </a:prstGeom>
-          <a:noFill/>
-        </p:spPr>
-        <p:txBody>
-          <a:bodyPr wrap="square" lIns="0" rIns="0" tIns="0" bIns="0" anchor="t">
-            <a:spAutoFit/>
-          </a:bodyPr>
-          <a:lstStyle/>
-          <a:p>
-            <a:pPr algn="l"/>
-            <a:r>
-              <a:rPr sz="20000" b="0" i="0">
+            <a:off x="6858000" y="1005840"/>
+            <a:ext cx="3108960" cy="2194560"/>
+          </a:xfrm>
+          <a:prstGeom prst="rect">
+            <a:avLst/>
+          </a:prstGeom>
+          <a:noFill/>
+        </p:spPr>
+        <p:txBody>
+          <a:bodyPr wrap="square" lIns="0" rIns="0" tIns="0" bIns="0" anchor="t">
+            <a:spAutoFit/>
+          </a:bodyPr>
+          <a:lstStyle/>
+          <a:p>
+            <a:pPr algn="l"/>
+            <a:r>
+              <a:rPr sz="16000" b="0" i="0">
                 <a:solidFill>
                   <a:srgbClr val="E4ECF7"/>
                 </a:solidFill>
@@ -9755,8 +9946,34 @@
               </a:rPr>
               <a:t>94</a:t>
             </a:r>
-            <a:r>
-              <a:rPr sz="20000" b="0" i="0">
+          </a:p>
+        </p:txBody>
+      </p:sp>
+      <p:sp>
+        <p:nvSpPr>
+          <p:cNvPr id="9" name="TextBox 8"/>
+          <p:cNvSpPr txBox="1"/>
+          <p:nvPr/>
+        </p:nvSpPr>
+        <p:spPr>
+          <a:xfrm>
+            <a:off x="9692640" y="1005840"/>
+            <a:ext cx="2194560" cy="2194560"/>
+          </a:xfrm>
+          <a:prstGeom prst="rect">
+            <a:avLst/>
+          </a:prstGeom>
+          <a:noFill/>
+        </p:spPr>
+        <p:txBody>
+          <a:bodyPr wrap="square" lIns="0" rIns="0" tIns="0" bIns="0" anchor="t">
+            <a:spAutoFit/>
+          </a:bodyPr>
+          <a:lstStyle/>
+          <a:p>
+            <a:pPr algn="l"/>
+            <a:r>
+              <a:rPr sz="16000" b="0" i="0">
                 <a:solidFill>
                   <a:srgbClr val="3EE887"/>
                 </a:solidFill>
@@ -9769,14 +9986,14 @@
       </p:sp>
       <p:sp>
         <p:nvSpPr>
-          <p:cNvPr id="9" name="TextBox 8"/>
-          <p:cNvSpPr txBox="1"/>
-          <p:nvPr/>
-        </p:nvSpPr>
-        <p:spPr>
-          <a:xfrm>
-            <a:off x="6858000" y="3383280"/>
-            <a:ext cx="4572000" cy="365760"/>
+          <p:cNvPr id="10" name="TextBox 9"/>
+          <p:cNvSpPr txBox="1"/>
+          <p:nvPr/>
+        </p:nvSpPr>
+        <p:spPr>
+          <a:xfrm>
+            <a:off x="6858000" y="3246120"/>
+            <a:ext cx="5029200" cy="365760"/>
           </a:xfrm>
           <a:prstGeom prst="rect">
             <a:avLst/>
@@ -9804,29 +10021,29 @@
       </p:sp>
       <p:sp>
         <p:nvSpPr>
-          <p:cNvPr id="10" name="TextBox 9"/>
-          <p:cNvSpPr txBox="1"/>
-          <p:nvPr/>
-        </p:nvSpPr>
-        <p:spPr>
-          <a:xfrm>
-            <a:off x="6858000" y="3931920"/>
-            <a:ext cx="2286000" cy="1188720"/>
-          </a:xfrm>
-          <a:prstGeom prst="rect">
-            <a:avLst/>
-          </a:prstGeom>
-          <a:noFill/>
-        </p:spPr>
-        <p:txBody>
-          <a:bodyPr wrap="square" lIns="0" rIns="0" tIns="0" bIns="0" anchor="t">
-            <a:spAutoFit/>
-          </a:bodyPr>
-          <a:lstStyle/>
-          <a:p>
-            <a:pPr algn="l"/>
-            <a:r>
-              <a:rPr sz="6000" b="0" i="0">
+          <p:cNvPr id="11" name="TextBox 10"/>
+          <p:cNvSpPr txBox="1"/>
+          <p:nvPr/>
+        </p:nvSpPr>
+        <p:spPr>
+          <a:xfrm>
+            <a:off x="6858000" y="3840480"/>
+            <a:ext cx="2743200" cy="1097280"/>
+          </a:xfrm>
+          <a:prstGeom prst="rect">
+            <a:avLst/>
+          </a:prstGeom>
+          <a:noFill/>
+        </p:spPr>
+        <p:txBody>
+          <a:bodyPr wrap="square" lIns="0" rIns="0" tIns="0" bIns="0" anchor="t">
+            <a:spAutoFit/>
+          </a:bodyPr>
+          <a:lstStyle/>
+          <a:p>
+            <a:pPr algn="l"/>
+            <a:r>
+              <a:rPr sz="5000" b="0" i="0">
                 <a:solidFill>
                   <a:srgbClr val="E4ECF7"/>
                 </a:solidFill>
@@ -9835,7 +10052,7 @@
               <a:t>86.5</a:t>
             </a:r>
             <a:r>
-              <a:rPr sz="6000" b="0" i="0">
+              <a:rPr sz="5000" b="0" i="0">
                 <a:solidFill>
                   <a:srgbClr val="E4ECF7"/>
                 </a:solidFill>
@@ -9844,7 +10061,7 @@
               <a:t>–</a:t>
             </a:r>
             <a:r>
-              <a:rPr sz="6000" b="0" i="0">
+              <a:rPr sz="5000" b="0" i="0">
                 <a:solidFill>
                   <a:srgbClr val="E4ECF7"/>
                 </a:solidFill>
@@ -9853,7 +10070,7 @@
               <a:t>91.3</a:t>
             </a:r>
             <a:r>
-              <a:rPr sz="6000" b="0" i="0">
+              <a:rPr sz="5000" b="0" i="0">
                 <a:solidFill>
                   <a:srgbClr val="3EE887"/>
                 </a:solidFill>
@@ -9866,14 +10083,14 @@
       </p:sp>
       <p:sp>
         <p:nvSpPr>
-          <p:cNvPr id="11" name="TextBox 10"/>
-          <p:cNvSpPr txBox="1"/>
-          <p:nvPr/>
-        </p:nvSpPr>
-        <p:spPr>
-          <a:xfrm>
-            <a:off x="6858000" y="5120640"/>
-            <a:ext cx="2743200" cy="365760"/>
+          <p:cNvPr id="12" name="TextBox 11"/>
+          <p:cNvSpPr txBox="1"/>
+          <p:nvPr/>
+        </p:nvSpPr>
+        <p:spPr>
+          <a:xfrm>
+            <a:off x="6858000" y="4983480"/>
+            <a:ext cx="3200400" cy="365760"/>
           </a:xfrm>
           <a:prstGeom prst="rect">
             <a:avLst/>
@@ -9901,29 +10118,29 @@
       </p:sp>
       <p:sp>
         <p:nvSpPr>
-          <p:cNvPr id="12" name="TextBox 11"/>
-          <p:cNvSpPr txBox="1"/>
-          <p:nvPr/>
-        </p:nvSpPr>
-        <p:spPr>
-          <a:xfrm>
-            <a:off x="9509760" y="3931920"/>
-            <a:ext cx="2286000" cy="1188720"/>
-          </a:xfrm>
-          <a:prstGeom prst="rect">
-            <a:avLst/>
-          </a:prstGeom>
-          <a:noFill/>
-        </p:spPr>
-        <p:txBody>
-          <a:bodyPr wrap="square" lIns="0" rIns="0" tIns="0" bIns="0" anchor="t">
-            <a:spAutoFit/>
-          </a:bodyPr>
-          <a:lstStyle/>
-          <a:p>
-            <a:pPr algn="l"/>
-            <a:r>
-              <a:rPr sz="6000" b="0" i="0">
+          <p:cNvPr id="13" name="TextBox 12"/>
+          <p:cNvSpPr txBox="1"/>
+          <p:nvPr/>
+        </p:nvSpPr>
+        <p:spPr>
+          <a:xfrm>
+            <a:off x="9784080" y="3840480"/>
+            <a:ext cx="2286000" cy="1097280"/>
+          </a:xfrm>
+          <a:prstGeom prst="rect">
+            <a:avLst/>
+          </a:prstGeom>
+          <a:noFill/>
+        </p:spPr>
+        <p:txBody>
+          <a:bodyPr wrap="square" lIns="0" rIns="0" tIns="0" bIns="0" anchor="t">
+            <a:spAutoFit/>
+          </a:bodyPr>
+          <a:lstStyle/>
+          <a:p>
+            <a:pPr algn="l"/>
+            <a:r>
+              <a:rPr sz="5000" b="0" i="0">
                 <a:solidFill>
                   <a:srgbClr val="E4ECF7"/>
                 </a:solidFill>
@@ -9932,7 +10149,7 @@
               <a:t>85.0</a:t>
             </a:r>
             <a:r>
-              <a:rPr sz="6000" b="0" i="0">
+              <a:rPr sz="5000" b="0" i="0">
                 <a:solidFill>
                   <a:srgbClr val="3EE887"/>
                 </a:solidFill>
@@ -9945,14 +10162,14 @@
       </p:sp>
       <p:sp>
         <p:nvSpPr>
-          <p:cNvPr id="13" name="TextBox 12"/>
-          <p:cNvSpPr txBox="1"/>
-          <p:nvPr/>
-        </p:nvSpPr>
-        <p:spPr>
-          <a:xfrm>
-            <a:off x="9509760" y="5120640"/>
-            <a:ext cx="2743200" cy="365760"/>
+          <p:cNvPr id="14" name="TextBox 13"/>
+          <p:cNvSpPr txBox="1"/>
+          <p:nvPr/>
+        </p:nvSpPr>
+        <p:spPr>
+          <a:xfrm>
+            <a:off x="9784080" y="4983480"/>
+            <a:ext cx="2286000" cy="365760"/>
           </a:xfrm>
           <a:prstGeom prst="rect">
             <a:avLst/>

</xml_diff>

<commit_message>
Pitch deck PPTX: fix slide 4 state colors to canonical palette
The PDF render had the state palette miswired (reasoning shown as green,
retrieval as cyan, creativity as orange, precision as purple, uncertainty
as gray). Canonical mapping per landing CSS is reasoning=cyan, retrieval=
green, creativity=purple, precision=yellow, uncertainty=orange.

- Swapped column header colors and bar markers to match canonical palette
- Dropped the baked-in glyph strip image (its colors were wrong) and
  replaced with native colored dot clusters whose colors we control

Co-Authored-By: Claude Opus 4.7 (1M context) <noreply@anthropic.com>
</commit_message>
<xml_diff>
--- a/pitch/GhostLine_Pitch_Deck.pptx
+++ b/pitch/GhostLine_Pitch_Deck.pptx
@@ -8983,42 +8983,233 @@
           </a:p>
         </p:txBody>
       </p:sp>
-      <p:pic>
-        <p:nvPicPr>
-          <p:cNvPr id="7" name="Picture 6" descr="signatures_strip.png"/>
-          <p:cNvPicPr>
-            <a:picLocks noChangeAspect="1"/>
-          </p:cNvPicPr>
-          <p:nvPr/>
-        </p:nvPicPr>
-        <p:blipFill>
-          <a:blip r:embed="rId2"/>
-          <a:stretch>
-            <a:fillRect/>
-          </a:stretch>
-        </p:blipFill>
-        <p:spPr>
-          <a:xfrm>
-            <a:off x="548640" y="2194560"/>
-            <a:ext cx="11064240" cy="978408"/>
-          </a:xfrm>
-          <a:prstGeom prst="rect">
-            <a:avLst/>
-          </a:prstGeom>
-        </p:spPr>
-      </p:pic>
-      <p:sp>
-        <p:nvSpPr>
-          <p:cNvPr id="8" name="Rectangle 7"/>
+      <p:sp>
+        <p:nvSpPr>
+          <p:cNvPr id="7" name="Oval 6"/>
           <p:cNvSpPr/>
           <p:nvPr/>
         </p:nvSpPr>
         <p:spPr>
           <a:xfrm>
-            <a:off x="548640" y="3291840"/>
-            <a:ext cx="2121408" cy="27432"/>
-          </a:xfrm>
-          <a:prstGeom prst="rect">
+            <a:off x="1383822" y="2336836"/>
+            <a:ext cx="91440" cy="91440"/>
+          </a:xfrm>
+          <a:prstGeom prst="ellipse">
+            <a:avLst/>
+          </a:prstGeom>
+          <a:solidFill>
+            <a:srgbClr val="4DD9FF"/>
+          </a:solidFill>
+          <a:ln>
+            <a:noFill/>
+          </a:ln>
+        </p:spPr>
+        <p:style>
+          <a:lnRef idx="1">
+            <a:schemeClr val="accent1"/>
+          </a:lnRef>
+          <a:fillRef idx="3">
+            <a:schemeClr val="accent1"/>
+          </a:fillRef>
+          <a:effectRef idx="2">
+            <a:schemeClr val="accent1"/>
+          </a:effectRef>
+          <a:fontRef idx="minor">
+            <a:schemeClr val="lt1"/>
+          </a:fontRef>
+        </p:style>
+        <p:txBody>
+          <a:bodyPr rtlCol="0" anchor="ctr"/>
+          <a:lstStyle/>
+          <a:p>
+            <a:pPr algn="ctr"/>
+          </a:p>
+        </p:txBody>
+      </p:sp>
+      <p:sp>
+        <p:nvSpPr>
+          <p:cNvPr id="8" name="Oval 7"/>
+          <p:cNvSpPr/>
+          <p:nvPr/>
+        </p:nvSpPr>
+        <p:spPr>
+          <a:xfrm>
+            <a:off x="1816280" y="2300362"/>
+            <a:ext cx="64008" cy="64008"/>
+          </a:xfrm>
+          <a:prstGeom prst="ellipse">
+            <a:avLst/>
+          </a:prstGeom>
+          <a:solidFill>
+            <a:srgbClr val="4DD9FF"/>
+          </a:solidFill>
+          <a:ln>
+            <a:noFill/>
+          </a:ln>
+        </p:spPr>
+        <p:style>
+          <a:lnRef idx="1">
+            <a:schemeClr val="accent1"/>
+          </a:lnRef>
+          <a:fillRef idx="3">
+            <a:schemeClr val="accent1"/>
+          </a:fillRef>
+          <a:effectRef idx="2">
+            <a:schemeClr val="accent1"/>
+          </a:effectRef>
+          <a:fontRef idx="minor">
+            <a:schemeClr val="lt1"/>
+          </a:fontRef>
+        </p:style>
+        <p:txBody>
+          <a:bodyPr rtlCol="0" anchor="ctr"/>
+          <a:lstStyle/>
+          <a:p>
+            <a:pPr algn="ctr"/>
+          </a:p>
+        </p:txBody>
+      </p:sp>
+      <p:sp>
+        <p:nvSpPr>
+          <p:cNvPr id="9" name="Oval 8"/>
+          <p:cNvSpPr/>
+          <p:nvPr/>
+        </p:nvSpPr>
+        <p:spPr>
+          <a:xfrm>
+            <a:off x="1668994" y="2488067"/>
+            <a:ext cx="64008" cy="64008"/>
+          </a:xfrm>
+          <a:prstGeom prst="ellipse">
+            <a:avLst/>
+          </a:prstGeom>
+          <a:solidFill>
+            <a:srgbClr val="4DD9FF"/>
+          </a:solidFill>
+          <a:ln>
+            <a:noFill/>
+          </a:ln>
+        </p:spPr>
+        <p:style>
+          <a:lnRef idx="1">
+            <a:schemeClr val="accent1"/>
+          </a:lnRef>
+          <a:fillRef idx="3">
+            <a:schemeClr val="accent1"/>
+          </a:fillRef>
+          <a:effectRef idx="2">
+            <a:schemeClr val="accent1"/>
+          </a:effectRef>
+          <a:fontRef idx="minor">
+            <a:schemeClr val="lt1"/>
+          </a:fontRef>
+        </p:style>
+        <p:txBody>
+          <a:bodyPr rtlCol="0" anchor="ctr"/>
+          <a:lstStyle/>
+          <a:p>
+            <a:pPr algn="ctr"/>
+          </a:p>
+        </p:txBody>
+      </p:sp>
+      <p:sp>
+        <p:nvSpPr>
+          <p:cNvPr id="10" name="Oval 9"/>
+          <p:cNvSpPr/>
+          <p:nvPr/>
+        </p:nvSpPr>
+        <p:spPr>
+          <a:xfrm>
+            <a:off x="1057228" y="2578795"/>
+            <a:ext cx="64008" cy="64008"/>
+          </a:xfrm>
+          <a:prstGeom prst="ellipse">
+            <a:avLst/>
+          </a:prstGeom>
+          <a:solidFill>
+            <a:srgbClr val="4DD9FF"/>
+          </a:solidFill>
+          <a:ln>
+            <a:noFill/>
+          </a:ln>
+        </p:spPr>
+        <p:style>
+          <a:lnRef idx="1">
+            <a:schemeClr val="accent1"/>
+          </a:lnRef>
+          <a:fillRef idx="3">
+            <a:schemeClr val="accent1"/>
+          </a:fillRef>
+          <a:effectRef idx="2">
+            <a:schemeClr val="accent1"/>
+          </a:effectRef>
+          <a:fontRef idx="minor">
+            <a:schemeClr val="lt1"/>
+          </a:fontRef>
+        </p:style>
+        <p:txBody>
+          <a:bodyPr rtlCol="0" anchor="ctr"/>
+          <a:lstStyle/>
+          <a:p>
+            <a:pPr algn="ctr"/>
+          </a:p>
+        </p:txBody>
+      </p:sp>
+      <p:sp>
+        <p:nvSpPr>
+          <p:cNvPr id="11" name="Oval 10"/>
+          <p:cNvSpPr/>
+          <p:nvPr/>
+        </p:nvSpPr>
+        <p:spPr>
+          <a:xfrm>
+            <a:off x="1030981" y="2531564"/>
+            <a:ext cx="64008" cy="64008"/>
+          </a:xfrm>
+          <a:prstGeom prst="ellipse">
+            <a:avLst/>
+          </a:prstGeom>
+          <a:solidFill>
+            <a:srgbClr val="4DD9FF"/>
+          </a:solidFill>
+          <a:ln>
+            <a:noFill/>
+          </a:ln>
+        </p:spPr>
+        <p:style>
+          <a:lnRef idx="1">
+            <a:schemeClr val="accent1"/>
+          </a:lnRef>
+          <a:fillRef idx="3">
+            <a:schemeClr val="accent1"/>
+          </a:fillRef>
+          <a:effectRef idx="2">
+            <a:schemeClr val="accent1"/>
+          </a:effectRef>
+          <a:fontRef idx="minor">
+            <a:schemeClr val="lt1"/>
+          </a:fontRef>
+        </p:style>
+        <p:txBody>
+          <a:bodyPr rtlCol="0" anchor="ctr"/>
+          <a:lstStyle/>
+          <a:p>
+            <a:pPr algn="ctr"/>
+          </a:p>
+        </p:txBody>
+      </p:sp>
+      <p:sp>
+        <p:nvSpPr>
+          <p:cNvPr id="12" name="Oval 11"/>
+          <p:cNvSpPr/>
+          <p:nvPr/>
+        </p:nvSpPr>
+        <p:spPr>
+          <a:xfrm>
+            <a:off x="3271539" y="2298344"/>
+            <a:ext cx="91440" cy="91440"/>
+          </a:xfrm>
+          <a:prstGeom prst="ellipse">
             <a:avLst/>
           </a:prstGeom>
           <a:solidFill>
@@ -9052,92 +9243,830 @@
       </p:sp>
       <p:sp>
         <p:nvSpPr>
-          <p:cNvPr id="9" name="TextBox 8"/>
-          <p:cNvSpPr txBox="1"/>
-          <p:nvPr/>
-        </p:nvSpPr>
-        <p:spPr>
-          <a:xfrm>
-            <a:off x="548640" y="3383280"/>
-            <a:ext cx="2121408" cy="292608"/>
-          </a:xfrm>
-          <a:prstGeom prst="rect">
-            <a:avLst/>
-          </a:prstGeom>
-          <a:noFill/>
-        </p:spPr>
-        <p:txBody>
-          <a:bodyPr wrap="square" lIns="0" rIns="0" tIns="0" bIns="0" anchor="t">
-            <a:spAutoFit/>
-          </a:bodyPr>
-          <a:lstStyle/>
-          <a:p>
-            <a:pPr algn="l"/>
-            <a:r>
-              <a:rPr sz="1200" b="1" i="0">
-                <a:solidFill>
-                  <a:srgbClr val="5CF2A8"/>
-                </a:solidFill>
-                <a:latin typeface="JetBrains Mono"/>
-              </a:rPr>
-              <a:t>01 / </a:t>
-            </a:r>
-            <a:r>
-              <a:rPr sz="1200" b="1" i="0" spc="150">
-                <a:solidFill>
-                  <a:srgbClr val="5CF2A8"/>
-                </a:solidFill>
-                <a:latin typeface="JetBrains Mono"/>
-              </a:rPr>
-              <a:t>REASONING</a:t>
-            </a:r>
-          </a:p>
-        </p:txBody>
-      </p:sp>
-      <p:sp>
-        <p:nvSpPr>
-          <p:cNvPr id="10" name="TextBox 9"/>
-          <p:cNvSpPr txBox="1"/>
-          <p:nvPr/>
-        </p:nvSpPr>
-        <p:spPr>
-          <a:xfrm>
-            <a:off x="548640" y="3749040"/>
-            <a:ext cx="2121408" cy="1828800"/>
-          </a:xfrm>
-          <a:prstGeom prst="rect">
-            <a:avLst/>
-          </a:prstGeom>
-          <a:noFill/>
-        </p:spPr>
-        <p:txBody>
-          <a:bodyPr wrap="square" lIns="0" rIns="0" tIns="0" bIns="0" anchor="t">
-            <a:spAutoFit/>
-          </a:bodyPr>
-          <a:lstStyle/>
-          <a:p>
-            <a:pPr algn="l"/>
-            <a:r>
-              <a:rPr sz="1150" b="0" i="0">
-                <a:solidFill>
-                  <a:srgbClr val="8A96AA"/>
-                </a:solidFill>
-                <a:latin typeface="Space Grotesk"/>
-              </a:rPr>
-              <a:t>High dimensional spread. Structured velocity. Consistent attention.</a:t>
-            </a:r>
-          </a:p>
-        </p:txBody>
-      </p:sp>
-      <p:sp>
-        <p:nvSpPr>
-          <p:cNvPr id="11" name="Rectangle 10"/>
+          <p:cNvPr id="13" name="Oval 12"/>
           <p:cNvSpPr/>
           <p:nvPr/>
         </p:nvSpPr>
         <p:spPr>
           <a:xfrm>
-            <a:off x="2761488" y="3291840"/>
+            <a:off x="3739281" y="2783247"/>
+            <a:ext cx="64008" cy="64008"/>
+          </a:xfrm>
+          <a:prstGeom prst="ellipse">
+            <a:avLst/>
+          </a:prstGeom>
+          <a:solidFill>
+            <a:srgbClr val="5CF2A8"/>
+          </a:solidFill>
+          <a:ln>
+            <a:noFill/>
+          </a:ln>
+        </p:spPr>
+        <p:style>
+          <a:lnRef idx="1">
+            <a:schemeClr val="accent1"/>
+          </a:lnRef>
+          <a:fillRef idx="3">
+            <a:schemeClr val="accent1"/>
+          </a:fillRef>
+          <a:effectRef idx="2">
+            <a:schemeClr val="accent1"/>
+          </a:effectRef>
+          <a:fontRef idx="minor">
+            <a:schemeClr val="lt1"/>
+          </a:fontRef>
+        </p:style>
+        <p:txBody>
+          <a:bodyPr rtlCol="0" anchor="ctr"/>
+          <a:lstStyle/>
+          <a:p>
+            <a:pPr algn="ctr"/>
+          </a:p>
+        </p:txBody>
+      </p:sp>
+      <p:sp>
+        <p:nvSpPr>
+          <p:cNvPr id="14" name="Oval 13"/>
+          <p:cNvSpPr/>
+          <p:nvPr/>
+        </p:nvSpPr>
+        <p:spPr>
+          <a:xfrm>
+            <a:off x="3354315" y="2396887"/>
+            <a:ext cx="64008" cy="64008"/>
+          </a:xfrm>
+          <a:prstGeom prst="ellipse">
+            <a:avLst/>
+          </a:prstGeom>
+          <a:solidFill>
+            <a:srgbClr val="5CF2A8"/>
+          </a:solidFill>
+          <a:ln>
+            <a:noFill/>
+          </a:ln>
+        </p:spPr>
+        <p:style>
+          <a:lnRef idx="1">
+            <a:schemeClr val="accent1"/>
+          </a:lnRef>
+          <a:fillRef idx="3">
+            <a:schemeClr val="accent1"/>
+          </a:fillRef>
+          <a:effectRef idx="2">
+            <a:schemeClr val="accent1"/>
+          </a:effectRef>
+          <a:fontRef idx="minor">
+            <a:schemeClr val="lt1"/>
+          </a:fontRef>
+        </p:style>
+        <p:txBody>
+          <a:bodyPr rtlCol="0" anchor="ctr"/>
+          <a:lstStyle/>
+          <a:p>
+            <a:pPr algn="ctr"/>
+          </a:p>
+        </p:txBody>
+      </p:sp>
+      <p:sp>
+        <p:nvSpPr>
+          <p:cNvPr id="15" name="Oval 14"/>
+          <p:cNvSpPr/>
+          <p:nvPr/>
+        </p:nvSpPr>
+        <p:spPr>
+          <a:xfrm>
+            <a:off x="3999042" y="2860605"/>
+            <a:ext cx="64008" cy="64008"/>
+          </a:xfrm>
+          <a:prstGeom prst="ellipse">
+            <a:avLst/>
+          </a:prstGeom>
+          <a:solidFill>
+            <a:srgbClr val="5CF2A8"/>
+          </a:solidFill>
+          <a:ln>
+            <a:noFill/>
+          </a:ln>
+        </p:spPr>
+        <p:style>
+          <a:lnRef idx="1">
+            <a:schemeClr val="accent1"/>
+          </a:lnRef>
+          <a:fillRef idx="3">
+            <a:schemeClr val="accent1"/>
+          </a:fillRef>
+          <a:effectRef idx="2">
+            <a:schemeClr val="accent1"/>
+          </a:effectRef>
+          <a:fontRef idx="minor">
+            <a:schemeClr val="lt1"/>
+          </a:fontRef>
+        </p:style>
+        <p:txBody>
+          <a:bodyPr rtlCol="0" anchor="ctr"/>
+          <a:lstStyle/>
+          <a:p>
+            <a:pPr algn="ctr"/>
+          </a:p>
+        </p:txBody>
+      </p:sp>
+      <p:sp>
+        <p:nvSpPr>
+          <p:cNvPr id="16" name="Oval 15"/>
+          <p:cNvSpPr/>
+          <p:nvPr/>
+        </p:nvSpPr>
+        <p:spPr>
+          <a:xfrm>
+            <a:off x="3934612" y="2507904"/>
+            <a:ext cx="64008" cy="64008"/>
+          </a:xfrm>
+          <a:prstGeom prst="ellipse">
+            <a:avLst/>
+          </a:prstGeom>
+          <a:solidFill>
+            <a:srgbClr val="5CF2A8"/>
+          </a:solidFill>
+          <a:ln>
+            <a:noFill/>
+          </a:ln>
+        </p:spPr>
+        <p:style>
+          <a:lnRef idx="1">
+            <a:schemeClr val="accent1"/>
+          </a:lnRef>
+          <a:fillRef idx="3">
+            <a:schemeClr val="accent1"/>
+          </a:fillRef>
+          <a:effectRef idx="2">
+            <a:schemeClr val="accent1"/>
+          </a:effectRef>
+          <a:fontRef idx="minor">
+            <a:schemeClr val="lt1"/>
+          </a:fontRef>
+        </p:style>
+        <p:txBody>
+          <a:bodyPr rtlCol="0" anchor="ctr"/>
+          <a:lstStyle/>
+          <a:p>
+            <a:pPr algn="ctr"/>
+          </a:p>
+        </p:txBody>
+      </p:sp>
+      <p:sp>
+        <p:nvSpPr>
+          <p:cNvPr id="17" name="Oval 16"/>
+          <p:cNvSpPr/>
+          <p:nvPr/>
+        </p:nvSpPr>
+        <p:spPr>
+          <a:xfrm>
+            <a:off x="6644722" y="2270097"/>
+            <a:ext cx="91440" cy="91440"/>
+          </a:xfrm>
+          <a:prstGeom prst="ellipse">
+            <a:avLst/>
+          </a:prstGeom>
+          <a:solidFill>
+            <a:srgbClr val="B466FF"/>
+          </a:solidFill>
+          <a:ln>
+            <a:noFill/>
+          </a:ln>
+        </p:spPr>
+        <p:style>
+          <a:lnRef idx="1">
+            <a:schemeClr val="accent1"/>
+          </a:lnRef>
+          <a:fillRef idx="3">
+            <a:schemeClr val="accent1"/>
+          </a:fillRef>
+          <a:effectRef idx="2">
+            <a:schemeClr val="accent1"/>
+          </a:effectRef>
+          <a:fontRef idx="minor">
+            <a:schemeClr val="lt1"/>
+          </a:fontRef>
+        </p:style>
+        <p:txBody>
+          <a:bodyPr rtlCol="0" anchor="ctr"/>
+          <a:lstStyle/>
+          <a:p>
+            <a:pPr algn="ctr"/>
+          </a:p>
+        </p:txBody>
+      </p:sp>
+      <p:sp>
+        <p:nvSpPr>
+          <p:cNvPr id="18" name="Oval 17"/>
+          <p:cNvSpPr/>
+          <p:nvPr/>
+        </p:nvSpPr>
+        <p:spPr>
+          <a:xfrm>
+            <a:off x="6507652" y="2439370"/>
+            <a:ext cx="64008" cy="64008"/>
+          </a:xfrm>
+          <a:prstGeom prst="ellipse">
+            <a:avLst/>
+          </a:prstGeom>
+          <a:solidFill>
+            <a:srgbClr val="B466FF"/>
+          </a:solidFill>
+          <a:ln>
+            <a:noFill/>
+          </a:ln>
+        </p:spPr>
+        <p:style>
+          <a:lnRef idx="1">
+            <a:schemeClr val="accent1"/>
+          </a:lnRef>
+          <a:fillRef idx="3">
+            <a:schemeClr val="accent1"/>
+          </a:fillRef>
+          <a:effectRef idx="2">
+            <a:schemeClr val="accent1"/>
+          </a:effectRef>
+          <a:fontRef idx="minor">
+            <a:schemeClr val="lt1"/>
+          </a:fontRef>
+        </p:style>
+        <p:txBody>
+          <a:bodyPr rtlCol="0" anchor="ctr"/>
+          <a:lstStyle/>
+          <a:p>
+            <a:pPr algn="ctr"/>
+          </a:p>
+        </p:txBody>
+      </p:sp>
+      <p:sp>
+        <p:nvSpPr>
+          <p:cNvPr id="19" name="Oval 18"/>
+          <p:cNvSpPr/>
+          <p:nvPr/>
+        </p:nvSpPr>
+        <p:spPr>
+          <a:xfrm>
+            <a:off x="5593346" y="2329393"/>
+            <a:ext cx="64008" cy="64008"/>
+          </a:xfrm>
+          <a:prstGeom prst="ellipse">
+            <a:avLst/>
+          </a:prstGeom>
+          <a:solidFill>
+            <a:srgbClr val="B466FF"/>
+          </a:solidFill>
+          <a:ln>
+            <a:noFill/>
+          </a:ln>
+        </p:spPr>
+        <p:style>
+          <a:lnRef idx="1">
+            <a:schemeClr val="accent1"/>
+          </a:lnRef>
+          <a:fillRef idx="3">
+            <a:schemeClr val="accent1"/>
+          </a:fillRef>
+          <a:effectRef idx="2">
+            <a:schemeClr val="accent1"/>
+          </a:effectRef>
+          <a:fontRef idx="minor">
+            <a:schemeClr val="lt1"/>
+          </a:fontRef>
+        </p:style>
+        <p:txBody>
+          <a:bodyPr rtlCol="0" anchor="ctr"/>
+          <a:lstStyle/>
+          <a:p>
+            <a:pPr algn="ctr"/>
+          </a:p>
+        </p:txBody>
+      </p:sp>
+      <p:sp>
+        <p:nvSpPr>
+          <p:cNvPr id="20" name="Oval 19"/>
+          <p:cNvSpPr/>
+          <p:nvPr/>
+        </p:nvSpPr>
+        <p:spPr>
+          <a:xfrm>
+            <a:off x="5803583" y="2776382"/>
+            <a:ext cx="64008" cy="64008"/>
+          </a:xfrm>
+          <a:prstGeom prst="ellipse">
+            <a:avLst/>
+          </a:prstGeom>
+          <a:solidFill>
+            <a:srgbClr val="B466FF"/>
+          </a:solidFill>
+          <a:ln>
+            <a:noFill/>
+          </a:ln>
+        </p:spPr>
+        <p:style>
+          <a:lnRef idx="1">
+            <a:schemeClr val="accent1"/>
+          </a:lnRef>
+          <a:fillRef idx="3">
+            <a:schemeClr val="accent1"/>
+          </a:fillRef>
+          <a:effectRef idx="2">
+            <a:schemeClr val="accent1"/>
+          </a:effectRef>
+          <a:fontRef idx="minor">
+            <a:schemeClr val="lt1"/>
+          </a:fontRef>
+        </p:style>
+        <p:txBody>
+          <a:bodyPr rtlCol="0" anchor="ctr"/>
+          <a:lstStyle/>
+          <a:p>
+            <a:pPr algn="ctr"/>
+          </a:p>
+        </p:txBody>
+      </p:sp>
+      <p:sp>
+        <p:nvSpPr>
+          <p:cNvPr id="21" name="Oval 20"/>
+          <p:cNvSpPr/>
+          <p:nvPr/>
+        </p:nvSpPr>
+        <p:spPr>
+          <a:xfrm>
+            <a:off x="5640035" y="2626266"/>
+            <a:ext cx="64008" cy="64008"/>
+          </a:xfrm>
+          <a:prstGeom prst="ellipse">
+            <a:avLst/>
+          </a:prstGeom>
+          <a:solidFill>
+            <a:srgbClr val="B466FF"/>
+          </a:solidFill>
+          <a:ln>
+            <a:noFill/>
+          </a:ln>
+        </p:spPr>
+        <p:style>
+          <a:lnRef idx="1">
+            <a:schemeClr val="accent1"/>
+          </a:lnRef>
+          <a:fillRef idx="3">
+            <a:schemeClr val="accent1"/>
+          </a:fillRef>
+          <a:effectRef idx="2">
+            <a:schemeClr val="accent1"/>
+          </a:effectRef>
+          <a:fontRef idx="minor">
+            <a:schemeClr val="lt1"/>
+          </a:fontRef>
+        </p:style>
+        <p:txBody>
+          <a:bodyPr rtlCol="0" anchor="ctr"/>
+          <a:lstStyle/>
+          <a:p>
+            <a:pPr algn="ctr"/>
+          </a:p>
+        </p:txBody>
+      </p:sp>
+      <p:sp>
+        <p:nvSpPr>
+          <p:cNvPr id="22" name="Oval 21"/>
+          <p:cNvSpPr/>
+          <p:nvPr/>
+        </p:nvSpPr>
+        <p:spPr>
+          <a:xfrm>
+            <a:off x="8425719" y="2478645"/>
+            <a:ext cx="91440" cy="91440"/>
+          </a:xfrm>
+          <a:prstGeom prst="ellipse">
+            <a:avLst/>
+          </a:prstGeom>
+          <a:solidFill>
+            <a:srgbClr val="FFD24D"/>
+          </a:solidFill>
+          <a:ln>
+            <a:noFill/>
+          </a:ln>
+        </p:spPr>
+        <p:style>
+          <a:lnRef idx="1">
+            <a:schemeClr val="accent1"/>
+          </a:lnRef>
+          <a:fillRef idx="3">
+            <a:schemeClr val="accent1"/>
+          </a:fillRef>
+          <a:effectRef idx="2">
+            <a:schemeClr val="accent1"/>
+          </a:effectRef>
+          <a:fontRef idx="minor">
+            <a:schemeClr val="lt1"/>
+          </a:fontRef>
+        </p:style>
+        <p:txBody>
+          <a:bodyPr rtlCol="0" anchor="ctr"/>
+          <a:lstStyle/>
+          <a:p>
+            <a:pPr algn="ctr"/>
+          </a:p>
+        </p:txBody>
+      </p:sp>
+      <p:sp>
+        <p:nvSpPr>
+          <p:cNvPr id="23" name="Oval 22"/>
+          <p:cNvSpPr/>
+          <p:nvPr/>
+        </p:nvSpPr>
+        <p:spPr>
+          <a:xfrm>
+            <a:off x="8322724" y="2294186"/>
+            <a:ext cx="64008" cy="64008"/>
+          </a:xfrm>
+          <a:prstGeom prst="ellipse">
+            <a:avLst/>
+          </a:prstGeom>
+          <a:solidFill>
+            <a:srgbClr val="FFD24D"/>
+          </a:solidFill>
+          <a:ln>
+            <a:noFill/>
+          </a:ln>
+        </p:spPr>
+        <p:style>
+          <a:lnRef idx="1">
+            <a:schemeClr val="accent1"/>
+          </a:lnRef>
+          <a:fillRef idx="3">
+            <a:schemeClr val="accent1"/>
+          </a:fillRef>
+          <a:effectRef idx="2">
+            <a:schemeClr val="accent1"/>
+          </a:effectRef>
+          <a:fontRef idx="minor">
+            <a:schemeClr val="lt1"/>
+          </a:fontRef>
+        </p:style>
+        <p:txBody>
+          <a:bodyPr rtlCol="0" anchor="ctr"/>
+          <a:lstStyle/>
+          <a:p>
+            <a:pPr algn="ctr"/>
+          </a:p>
+        </p:txBody>
+      </p:sp>
+      <p:sp>
+        <p:nvSpPr>
+          <p:cNvPr id="24" name="Oval 23"/>
+          <p:cNvSpPr/>
+          <p:nvPr/>
+        </p:nvSpPr>
+        <p:spPr>
+          <a:xfrm>
+            <a:off x="7697824" y="2385827"/>
+            <a:ext cx="64008" cy="64008"/>
+          </a:xfrm>
+          <a:prstGeom prst="ellipse">
+            <a:avLst/>
+          </a:prstGeom>
+          <a:solidFill>
+            <a:srgbClr val="FFD24D"/>
+          </a:solidFill>
+          <a:ln>
+            <a:noFill/>
+          </a:ln>
+        </p:spPr>
+        <p:style>
+          <a:lnRef idx="1">
+            <a:schemeClr val="accent1"/>
+          </a:lnRef>
+          <a:fillRef idx="3">
+            <a:schemeClr val="accent1"/>
+          </a:fillRef>
+          <a:effectRef idx="2">
+            <a:schemeClr val="accent1"/>
+          </a:effectRef>
+          <a:fontRef idx="minor">
+            <a:schemeClr val="lt1"/>
+          </a:fontRef>
+        </p:style>
+        <p:txBody>
+          <a:bodyPr rtlCol="0" anchor="ctr"/>
+          <a:lstStyle/>
+          <a:p>
+            <a:pPr algn="ctr"/>
+          </a:p>
+        </p:txBody>
+      </p:sp>
+      <p:sp>
+        <p:nvSpPr>
+          <p:cNvPr id="25" name="Oval 24"/>
+          <p:cNvSpPr/>
+          <p:nvPr/>
+        </p:nvSpPr>
+        <p:spPr>
+          <a:xfrm>
+            <a:off x="8492544" y="2527690"/>
+            <a:ext cx="64008" cy="64008"/>
+          </a:xfrm>
+          <a:prstGeom prst="ellipse">
+            <a:avLst/>
+          </a:prstGeom>
+          <a:solidFill>
+            <a:srgbClr val="FFD24D"/>
+          </a:solidFill>
+          <a:ln>
+            <a:noFill/>
+          </a:ln>
+        </p:spPr>
+        <p:style>
+          <a:lnRef idx="1">
+            <a:schemeClr val="accent1"/>
+          </a:lnRef>
+          <a:fillRef idx="3">
+            <a:schemeClr val="accent1"/>
+          </a:fillRef>
+          <a:effectRef idx="2">
+            <a:schemeClr val="accent1"/>
+          </a:effectRef>
+          <a:fontRef idx="minor">
+            <a:schemeClr val="lt1"/>
+          </a:fontRef>
+        </p:style>
+        <p:txBody>
+          <a:bodyPr rtlCol="0" anchor="ctr"/>
+          <a:lstStyle/>
+          <a:p>
+            <a:pPr algn="ctr"/>
+          </a:p>
+        </p:txBody>
+      </p:sp>
+      <p:sp>
+        <p:nvSpPr>
+          <p:cNvPr id="26" name="Oval 25"/>
+          <p:cNvSpPr/>
+          <p:nvPr/>
+        </p:nvSpPr>
+        <p:spPr>
+          <a:xfrm>
+            <a:off x="8023683" y="2628802"/>
+            <a:ext cx="64008" cy="64008"/>
+          </a:xfrm>
+          <a:prstGeom prst="ellipse">
+            <a:avLst/>
+          </a:prstGeom>
+          <a:solidFill>
+            <a:srgbClr val="FFD24D"/>
+          </a:solidFill>
+          <a:ln>
+            <a:noFill/>
+          </a:ln>
+        </p:spPr>
+        <p:style>
+          <a:lnRef idx="1">
+            <a:schemeClr val="accent1"/>
+          </a:lnRef>
+          <a:fillRef idx="3">
+            <a:schemeClr val="accent1"/>
+          </a:fillRef>
+          <a:effectRef idx="2">
+            <a:schemeClr val="accent1"/>
+          </a:effectRef>
+          <a:fontRef idx="minor">
+            <a:schemeClr val="lt1"/>
+          </a:fontRef>
+        </p:style>
+        <p:txBody>
+          <a:bodyPr rtlCol="0" anchor="ctr"/>
+          <a:lstStyle/>
+          <a:p>
+            <a:pPr algn="ctr"/>
+          </a:p>
+        </p:txBody>
+      </p:sp>
+      <p:sp>
+        <p:nvSpPr>
+          <p:cNvPr id="27" name="Oval 26"/>
+          <p:cNvSpPr/>
+          <p:nvPr/>
+        </p:nvSpPr>
+        <p:spPr>
+          <a:xfrm>
+            <a:off x="10400805" y="2432155"/>
+            <a:ext cx="91440" cy="91440"/>
+          </a:xfrm>
+          <a:prstGeom prst="ellipse">
+            <a:avLst/>
+          </a:prstGeom>
+          <a:solidFill>
+            <a:srgbClr val="FF9C52"/>
+          </a:solidFill>
+          <a:ln>
+            <a:noFill/>
+          </a:ln>
+        </p:spPr>
+        <p:style>
+          <a:lnRef idx="1">
+            <a:schemeClr val="accent1"/>
+          </a:lnRef>
+          <a:fillRef idx="3">
+            <a:schemeClr val="accent1"/>
+          </a:fillRef>
+          <a:effectRef idx="2">
+            <a:schemeClr val="accent1"/>
+          </a:effectRef>
+          <a:fontRef idx="minor">
+            <a:schemeClr val="lt1"/>
+          </a:fontRef>
+        </p:style>
+        <p:txBody>
+          <a:bodyPr rtlCol="0" anchor="ctr"/>
+          <a:lstStyle/>
+          <a:p>
+            <a:pPr algn="ctr"/>
+          </a:p>
+        </p:txBody>
+      </p:sp>
+      <p:sp>
+        <p:nvSpPr>
+          <p:cNvPr id="28" name="Oval 27"/>
+          <p:cNvSpPr/>
+          <p:nvPr/>
+        </p:nvSpPr>
+        <p:spPr>
+          <a:xfrm>
+            <a:off x="10851304" y="2701408"/>
+            <a:ext cx="64008" cy="64008"/>
+          </a:xfrm>
+          <a:prstGeom prst="ellipse">
+            <a:avLst/>
+          </a:prstGeom>
+          <a:solidFill>
+            <a:srgbClr val="FF9C52"/>
+          </a:solidFill>
+          <a:ln>
+            <a:noFill/>
+          </a:ln>
+        </p:spPr>
+        <p:style>
+          <a:lnRef idx="1">
+            <a:schemeClr val="accent1"/>
+          </a:lnRef>
+          <a:fillRef idx="3">
+            <a:schemeClr val="accent1"/>
+          </a:fillRef>
+          <a:effectRef idx="2">
+            <a:schemeClr val="accent1"/>
+          </a:effectRef>
+          <a:fontRef idx="minor">
+            <a:schemeClr val="lt1"/>
+          </a:fontRef>
+        </p:style>
+        <p:txBody>
+          <a:bodyPr rtlCol="0" anchor="ctr"/>
+          <a:lstStyle/>
+          <a:p>
+            <a:pPr algn="ctr"/>
+          </a:p>
+        </p:txBody>
+      </p:sp>
+      <p:sp>
+        <p:nvSpPr>
+          <p:cNvPr id="29" name="Oval 28"/>
+          <p:cNvSpPr/>
+          <p:nvPr/>
+        </p:nvSpPr>
+        <p:spPr>
+          <a:xfrm>
+            <a:off x="10146855" y="2621673"/>
+            <a:ext cx="64008" cy="64008"/>
+          </a:xfrm>
+          <a:prstGeom prst="ellipse">
+            <a:avLst/>
+          </a:prstGeom>
+          <a:solidFill>
+            <a:srgbClr val="FF9C52"/>
+          </a:solidFill>
+          <a:ln>
+            <a:noFill/>
+          </a:ln>
+        </p:spPr>
+        <p:style>
+          <a:lnRef idx="1">
+            <a:schemeClr val="accent1"/>
+          </a:lnRef>
+          <a:fillRef idx="3">
+            <a:schemeClr val="accent1"/>
+          </a:fillRef>
+          <a:effectRef idx="2">
+            <a:schemeClr val="accent1"/>
+          </a:effectRef>
+          <a:fontRef idx="minor">
+            <a:schemeClr val="lt1"/>
+          </a:fontRef>
+        </p:style>
+        <p:txBody>
+          <a:bodyPr rtlCol="0" anchor="ctr"/>
+          <a:lstStyle/>
+          <a:p>
+            <a:pPr algn="ctr"/>
+          </a:p>
+        </p:txBody>
+      </p:sp>
+      <p:sp>
+        <p:nvSpPr>
+          <p:cNvPr id="30" name="Oval 29"/>
+          <p:cNvSpPr/>
+          <p:nvPr/>
+        </p:nvSpPr>
+        <p:spPr>
+          <a:xfrm>
+            <a:off x="10506707" y="2814154"/>
+            <a:ext cx="64008" cy="64008"/>
+          </a:xfrm>
+          <a:prstGeom prst="ellipse">
+            <a:avLst/>
+          </a:prstGeom>
+          <a:solidFill>
+            <a:srgbClr val="FF9C52"/>
+          </a:solidFill>
+          <a:ln>
+            <a:noFill/>
+          </a:ln>
+        </p:spPr>
+        <p:style>
+          <a:lnRef idx="1">
+            <a:schemeClr val="accent1"/>
+          </a:lnRef>
+          <a:fillRef idx="3">
+            <a:schemeClr val="accent1"/>
+          </a:fillRef>
+          <a:effectRef idx="2">
+            <a:schemeClr val="accent1"/>
+          </a:effectRef>
+          <a:fontRef idx="minor">
+            <a:schemeClr val="lt1"/>
+          </a:fontRef>
+        </p:style>
+        <p:txBody>
+          <a:bodyPr rtlCol="0" anchor="ctr"/>
+          <a:lstStyle/>
+          <a:p>
+            <a:pPr algn="ctr"/>
+          </a:p>
+        </p:txBody>
+      </p:sp>
+      <p:sp>
+        <p:nvSpPr>
+          <p:cNvPr id="31" name="Oval 30"/>
+          <p:cNvSpPr/>
+          <p:nvPr/>
+        </p:nvSpPr>
+        <p:spPr>
+          <a:xfrm>
+            <a:off x="10768178" y="2438300"/>
+            <a:ext cx="64008" cy="64008"/>
+          </a:xfrm>
+          <a:prstGeom prst="ellipse">
+            <a:avLst/>
+          </a:prstGeom>
+          <a:solidFill>
+            <a:srgbClr val="FF9C52"/>
+          </a:solidFill>
+          <a:ln>
+            <a:noFill/>
+          </a:ln>
+        </p:spPr>
+        <p:style>
+          <a:lnRef idx="1">
+            <a:schemeClr val="accent1"/>
+          </a:lnRef>
+          <a:fillRef idx="3">
+            <a:schemeClr val="accent1"/>
+          </a:fillRef>
+          <a:effectRef idx="2">
+            <a:schemeClr val="accent1"/>
+          </a:effectRef>
+          <a:fontRef idx="minor">
+            <a:schemeClr val="lt1"/>
+          </a:fontRef>
+        </p:style>
+        <p:txBody>
+          <a:bodyPr rtlCol="0" anchor="ctr"/>
+          <a:lstStyle/>
+          <a:p>
+            <a:pPr algn="ctr"/>
+          </a:p>
+        </p:txBody>
+      </p:sp>
+      <p:sp>
+        <p:nvSpPr>
+          <p:cNvPr id="32" name="Rectangle 31"/>
+          <p:cNvSpPr/>
+          <p:nvPr/>
+        </p:nvSpPr>
+        <p:spPr>
+          <a:xfrm>
+            <a:off x="548640" y="3291840"/>
             <a:ext cx="2121408" cy="27432"/>
           </a:xfrm>
           <a:prstGeom prst="rect">
@@ -9174,7 +10103,129 @@
       </p:sp>
       <p:sp>
         <p:nvSpPr>
-          <p:cNvPr id="12" name="TextBox 11"/>
+          <p:cNvPr id="33" name="TextBox 32"/>
+          <p:cNvSpPr txBox="1"/>
+          <p:nvPr/>
+        </p:nvSpPr>
+        <p:spPr>
+          <a:xfrm>
+            <a:off x="548640" y="3383280"/>
+            <a:ext cx="2121408" cy="292608"/>
+          </a:xfrm>
+          <a:prstGeom prst="rect">
+            <a:avLst/>
+          </a:prstGeom>
+          <a:noFill/>
+        </p:spPr>
+        <p:txBody>
+          <a:bodyPr wrap="square" lIns="0" rIns="0" tIns="0" bIns="0" anchor="t">
+            <a:spAutoFit/>
+          </a:bodyPr>
+          <a:lstStyle/>
+          <a:p>
+            <a:pPr algn="l"/>
+            <a:r>
+              <a:rPr sz="1200" b="1" i="0">
+                <a:solidFill>
+                  <a:srgbClr val="4DD9FF"/>
+                </a:solidFill>
+                <a:latin typeface="JetBrains Mono"/>
+              </a:rPr>
+              <a:t>01 / </a:t>
+            </a:r>
+            <a:r>
+              <a:rPr sz="1200" b="1" i="0" spc="150">
+                <a:solidFill>
+                  <a:srgbClr val="4DD9FF"/>
+                </a:solidFill>
+                <a:latin typeface="JetBrains Mono"/>
+              </a:rPr>
+              <a:t>REASONING</a:t>
+            </a:r>
+          </a:p>
+        </p:txBody>
+      </p:sp>
+      <p:sp>
+        <p:nvSpPr>
+          <p:cNvPr id="34" name="TextBox 33"/>
+          <p:cNvSpPr txBox="1"/>
+          <p:nvPr/>
+        </p:nvSpPr>
+        <p:spPr>
+          <a:xfrm>
+            <a:off x="548640" y="3749040"/>
+            <a:ext cx="2121408" cy="1828800"/>
+          </a:xfrm>
+          <a:prstGeom prst="rect">
+            <a:avLst/>
+          </a:prstGeom>
+          <a:noFill/>
+        </p:spPr>
+        <p:txBody>
+          <a:bodyPr wrap="square" lIns="0" rIns="0" tIns="0" bIns="0" anchor="t">
+            <a:spAutoFit/>
+          </a:bodyPr>
+          <a:lstStyle/>
+          <a:p>
+            <a:pPr algn="l"/>
+            <a:r>
+              <a:rPr sz="1150" b="0" i="0">
+                <a:solidFill>
+                  <a:srgbClr val="8A96AA"/>
+                </a:solidFill>
+                <a:latin typeface="Space Grotesk"/>
+              </a:rPr>
+              <a:t>High dimensional spread. Structured velocity. Consistent attention.</a:t>
+            </a:r>
+          </a:p>
+        </p:txBody>
+      </p:sp>
+      <p:sp>
+        <p:nvSpPr>
+          <p:cNvPr id="35" name="Rectangle 34"/>
+          <p:cNvSpPr/>
+          <p:nvPr/>
+        </p:nvSpPr>
+        <p:spPr>
+          <a:xfrm>
+            <a:off x="2761488" y="3291840"/>
+            <a:ext cx="2121408" cy="27432"/>
+          </a:xfrm>
+          <a:prstGeom prst="rect">
+            <a:avLst/>
+          </a:prstGeom>
+          <a:solidFill>
+            <a:srgbClr val="5CF2A8"/>
+          </a:solidFill>
+          <a:ln>
+            <a:noFill/>
+          </a:ln>
+        </p:spPr>
+        <p:style>
+          <a:lnRef idx="1">
+            <a:schemeClr val="accent1"/>
+          </a:lnRef>
+          <a:fillRef idx="3">
+            <a:schemeClr val="accent1"/>
+          </a:fillRef>
+          <a:effectRef idx="2">
+            <a:schemeClr val="accent1"/>
+          </a:effectRef>
+          <a:fontRef idx="minor">
+            <a:schemeClr val="lt1"/>
+          </a:fontRef>
+        </p:style>
+        <p:txBody>
+          <a:bodyPr rtlCol="0" anchor="ctr"/>
+          <a:lstStyle/>
+          <a:p>
+            <a:pPr algn="ctr"/>
+          </a:p>
+        </p:txBody>
+      </p:sp>
+      <p:sp>
+        <p:nvSpPr>
+          <p:cNvPr id="36" name="TextBox 35"/>
           <p:cNvSpPr txBox="1"/>
           <p:nvPr/>
         </p:nvSpPr>
@@ -9198,7 +10249,7 @@
             <a:r>
               <a:rPr sz="1200" b="1" i="0">
                 <a:solidFill>
-                  <a:srgbClr val="4DD9FF"/>
+                  <a:srgbClr val="5CF2A8"/>
                 </a:solidFill>
                 <a:latin typeface="JetBrains Mono"/>
               </a:rPr>
@@ -9207,7 +10258,7 @@
             <a:r>
               <a:rPr sz="1200" b="1" i="0" spc="150">
                 <a:solidFill>
-                  <a:srgbClr val="4DD9FF"/>
+                  <a:srgbClr val="5CF2A8"/>
                 </a:solidFill>
                 <a:latin typeface="JetBrains Mono"/>
               </a:rPr>
@@ -9218,7 +10269,7 @@
       </p:sp>
       <p:sp>
         <p:nvSpPr>
-          <p:cNvPr id="13" name="TextBox 12"/>
+          <p:cNvPr id="37" name="TextBox 36"/>
           <p:cNvSpPr txBox="1"/>
           <p:nvPr/>
         </p:nvSpPr>
@@ -9253,13 +10304,257 @@
       </p:sp>
       <p:sp>
         <p:nvSpPr>
-          <p:cNvPr id="14" name="Rectangle 13"/>
+          <p:cNvPr id="38" name="Rectangle 37"/>
           <p:cNvSpPr/>
           <p:nvPr/>
         </p:nvSpPr>
         <p:spPr>
           <a:xfrm>
             <a:off x="4974336" y="3291840"/>
+            <a:ext cx="2121408" cy="27432"/>
+          </a:xfrm>
+          <a:prstGeom prst="rect">
+            <a:avLst/>
+          </a:prstGeom>
+          <a:solidFill>
+            <a:srgbClr val="B466FF"/>
+          </a:solidFill>
+          <a:ln>
+            <a:noFill/>
+          </a:ln>
+        </p:spPr>
+        <p:style>
+          <a:lnRef idx="1">
+            <a:schemeClr val="accent1"/>
+          </a:lnRef>
+          <a:fillRef idx="3">
+            <a:schemeClr val="accent1"/>
+          </a:fillRef>
+          <a:effectRef idx="2">
+            <a:schemeClr val="accent1"/>
+          </a:effectRef>
+          <a:fontRef idx="minor">
+            <a:schemeClr val="lt1"/>
+          </a:fontRef>
+        </p:style>
+        <p:txBody>
+          <a:bodyPr rtlCol="0" anchor="ctr"/>
+          <a:lstStyle/>
+          <a:p>
+            <a:pPr algn="ctr"/>
+          </a:p>
+        </p:txBody>
+      </p:sp>
+      <p:sp>
+        <p:nvSpPr>
+          <p:cNvPr id="39" name="TextBox 38"/>
+          <p:cNvSpPr txBox="1"/>
+          <p:nvPr/>
+        </p:nvSpPr>
+        <p:spPr>
+          <a:xfrm>
+            <a:off x="4974336" y="3383280"/>
+            <a:ext cx="2121408" cy="292608"/>
+          </a:xfrm>
+          <a:prstGeom prst="rect">
+            <a:avLst/>
+          </a:prstGeom>
+          <a:noFill/>
+        </p:spPr>
+        <p:txBody>
+          <a:bodyPr wrap="square" lIns="0" rIns="0" tIns="0" bIns="0" anchor="t">
+            <a:spAutoFit/>
+          </a:bodyPr>
+          <a:lstStyle/>
+          <a:p>
+            <a:pPr algn="l"/>
+            <a:r>
+              <a:rPr sz="1200" b="1" i="0">
+                <a:solidFill>
+                  <a:srgbClr val="B466FF"/>
+                </a:solidFill>
+                <a:latin typeface="JetBrains Mono"/>
+              </a:rPr>
+              <a:t>03 / </a:t>
+            </a:r>
+            <a:r>
+              <a:rPr sz="1200" b="1" i="0" spc="150">
+                <a:solidFill>
+                  <a:srgbClr val="B466FF"/>
+                </a:solidFill>
+                <a:latin typeface="JetBrains Mono"/>
+              </a:rPr>
+              <a:t>CREATIVITY</a:t>
+            </a:r>
+          </a:p>
+        </p:txBody>
+      </p:sp>
+      <p:sp>
+        <p:nvSpPr>
+          <p:cNvPr id="40" name="TextBox 39"/>
+          <p:cNvSpPr txBox="1"/>
+          <p:nvPr/>
+        </p:nvSpPr>
+        <p:spPr>
+          <a:xfrm>
+            <a:off x="4974336" y="3749040"/>
+            <a:ext cx="2121408" cy="1828800"/>
+          </a:xfrm>
+          <a:prstGeom prst="rect">
+            <a:avLst/>
+          </a:prstGeom>
+          <a:noFill/>
+        </p:spPr>
+        <p:txBody>
+          <a:bodyPr wrap="square" lIns="0" rIns="0" tIns="0" bIns="0" anchor="t">
+            <a:spAutoFit/>
+          </a:bodyPr>
+          <a:lstStyle/>
+          <a:p>
+            <a:pPr algn="l"/>
+            <a:r>
+              <a:rPr sz="1150" b="0" i="0">
+                <a:solidFill>
+                  <a:srgbClr val="8A96AA"/>
+                </a:solidFill>
+                <a:latin typeface="Space Grotesk"/>
+              </a:rPr>
+              <a:t>Widest dimensional spread. Exploratory attention.</a:t>
+            </a:r>
+          </a:p>
+        </p:txBody>
+      </p:sp>
+      <p:sp>
+        <p:nvSpPr>
+          <p:cNvPr id="41" name="Rectangle 40"/>
+          <p:cNvSpPr/>
+          <p:nvPr/>
+        </p:nvSpPr>
+        <p:spPr>
+          <a:xfrm>
+            <a:off x="7187184" y="3291840"/>
+            <a:ext cx="2121408" cy="27432"/>
+          </a:xfrm>
+          <a:prstGeom prst="rect">
+            <a:avLst/>
+          </a:prstGeom>
+          <a:solidFill>
+            <a:srgbClr val="FFD24D"/>
+          </a:solidFill>
+          <a:ln>
+            <a:noFill/>
+          </a:ln>
+        </p:spPr>
+        <p:style>
+          <a:lnRef idx="1">
+            <a:schemeClr val="accent1"/>
+          </a:lnRef>
+          <a:fillRef idx="3">
+            <a:schemeClr val="accent1"/>
+          </a:fillRef>
+          <a:effectRef idx="2">
+            <a:schemeClr val="accent1"/>
+          </a:effectRef>
+          <a:fontRef idx="minor">
+            <a:schemeClr val="lt1"/>
+          </a:fontRef>
+        </p:style>
+        <p:txBody>
+          <a:bodyPr rtlCol="0" anchor="ctr"/>
+          <a:lstStyle/>
+          <a:p>
+            <a:pPr algn="ctr"/>
+          </a:p>
+        </p:txBody>
+      </p:sp>
+      <p:sp>
+        <p:nvSpPr>
+          <p:cNvPr id="42" name="TextBox 41"/>
+          <p:cNvSpPr txBox="1"/>
+          <p:nvPr/>
+        </p:nvSpPr>
+        <p:spPr>
+          <a:xfrm>
+            <a:off x="7187184" y="3383280"/>
+            <a:ext cx="2121408" cy="292608"/>
+          </a:xfrm>
+          <a:prstGeom prst="rect">
+            <a:avLst/>
+          </a:prstGeom>
+          <a:noFill/>
+        </p:spPr>
+        <p:txBody>
+          <a:bodyPr wrap="square" lIns="0" rIns="0" tIns="0" bIns="0" anchor="t">
+            <a:spAutoFit/>
+          </a:bodyPr>
+          <a:lstStyle/>
+          <a:p>
+            <a:pPr algn="l"/>
+            <a:r>
+              <a:rPr sz="1200" b="1" i="0">
+                <a:solidFill>
+                  <a:srgbClr val="FFD24D"/>
+                </a:solidFill>
+                <a:latin typeface="JetBrains Mono"/>
+              </a:rPr>
+              <a:t>04 / </a:t>
+            </a:r>
+            <a:r>
+              <a:rPr sz="1200" b="1" i="0" spc="150">
+                <a:solidFill>
+                  <a:srgbClr val="FFD24D"/>
+                </a:solidFill>
+                <a:latin typeface="JetBrains Mono"/>
+              </a:rPr>
+              <a:t>PRECISION</a:t>
+            </a:r>
+          </a:p>
+        </p:txBody>
+      </p:sp>
+      <p:sp>
+        <p:nvSpPr>
+          <p:cNvPr id="43" name="TextBox 42"/>
+          <p:cNvSpPr txBox="1"/>
+          <p:nvPr/>
+        </p:nvSpPr>
+        <p:spPr>
+          <a:xfrm>
+            <a:off x="7187184" y="3749040"/>
+            <a:ext cx="2121408" cy="1828800"/>
+          </a:xfrm>
+          <a:prstGeom prst="rect">
+            <a:avLst/>
+          </a:prstGeom>
+          <a:noFill/>
+        </p:spPr>
+        <p:txBody>
+          <a:bodyPr wrap="square" lIns="0" rIns="0" tIns="0" bIns="0" anchor="t">
+            <a:spAutoFit/>
+          </a:bodyPr>
+          <a:lstStyle/>
+          <a:p>
+            <a:pPr algn="l"/>
+            <a:r>
+              <a:rPr sz="1150" b="0" i="0">
+                <a:solidFill>
+                  <a:srgbClr val="8A96AA"/>
+                </a:solidFill>
+                <a:latin typeface="Space Grotesk"/>
+              </a:rPr>
+              <a:t>Highest per-token focus. Moderate trajectory spread.</a:t>
+            </a:r>
+          </a:p>
+        </p:txBody>
+      </p:sp>
+      <p:sp>
+        <p:nvSpPr>
+          <p:cNvPr id="44" name="Rectangle 43"/>
+          <p:cNvSpPr/>
+          <p:nvPr/>
+        </p:nvSpPr>
+        <p:spPr>
+          <a:xfrm>
+            <a:off x="9400032" y="3291840"/>
             <a:ext cx="2121408" cy="27432"/>
           </a:xfrm>
           <a:prstGeom prst="rect">
@@ -9296,251 +10591,7 @@
       </p:sp>
       <p:sp>
         <p:nvSpPr>
-          <p:cNvPr id="15" name="TextBox 14"/>
-          <p:cNvSpPr txBox="1"/>
-          <p:nvPr/>
-        </p:nvSpPr>
-        <p:spPr>
-          <a:xfrm>
-            <a:off x="4974336" y="3383280"/>
-            <a:ext cx="2121408" cy="292608"/>
-          </a:xfrm>
-          <a:prstGeom prst="rect">
-            <a:avLst/>
-          </a:prstGeom>
-          <a:noFill/>
-        </p:spPr>
-        <p:txBody>
-          <a:bodyPr wrap="square" lIns="0" rIns="0" tIns="0" bIns="0" anchor="t">
-            <a:spAutoFit/>
-          </a:bodyPr>
-          <a:lstStyle/>
-          <a:p>
-            <a:pPr algn="l"/>
-            <a:r>
-              <a:rPr sz="1200" b="1" i="0">
-                <a:solidFill>
-                  <a:srgbClr val="FF9C52"/>
-                </a:solidFill>
-                <a:latin typeface="JetBrains Mono"/>
-              </a:rPr>
-              <a:t>03 / </a:t>
-            </a:r>
-            <a:r>
-              <a:rPr sz="1200" b="1" i="0" spc="150">
-                <a:solidFill>
-                  <a:srgbClr val="FF9C52"/>
-                </a:solidFill>
-                <a:latin typeface="JetBrains Mono"/>
-              </a:rPr>
-              <a:t>CREATIVITY</a:t>
-            </a:r>
-          </a:p>
-        </p:txBody>
-      </p:sp>
-      <p:sp>
-        <p:nvSpPr>
-          <p:cNvPr id="16" name="TextBox 15"/>
-          <p:cNvSpPr txBox="1"/>
-          <p:nvPr/>
-        </p:nvSpPr>
-        <p:spPr>
-          <a:xfrm>
-            <a:off x="4974336" y="3749040"/>
-            <a:ext cx="2121408" cy="1828800"/>
-          </a:xfrm>
-          <a:prstGeom prst="rect">
-            <a:avLst/>
-          </a:prstGeom>
-          <a:noFill/>
-        </p:spPr>
-        <p:txBody>
-          <a:bodyPr wrap="square" lIns="0" rIns="0" tIns="0" bIns="0" anchor="t">
-            <a:spAutoFit/>
-          </a:bodyPr>
-          <a:lstStyle/>
-          <a:p>
-            <a:pPr algn="l"/>
-            <a:r>
-              <a:rPr sz="1150" b="0" i="0">
-                <a:solidFill>
-                  <a:srgbClr val="8A96AA"/>
-                </a:solidFill>
-                <a:latin typeface="Space Grotesk"/>
-              </a:rPr>
-              <a:t>Widest dimensional spread. Exploratory attention.</a:t>
-            </a:r>
-          </a:p>
-        </p:txBody>
-      </p:sp>
-      <p:sp>
-        <p:nvSpPr>
-          <p:cNvPr id="17" name="Rectangle 16"/>
-          <p:cNvSpPr/>
-          <p:nvPr/>
-        </p:nvSpPr>
-        <p:spPr>
-          <a:xfrm>
-            <a:off x="7187184" y="3291840"/>
-            <a:ext cx="2121408" cy="27432"/>
-          </a:xfrm>
-          <a:prstGeom prst="rect">
-            <a:avLst/>
-          </a:prstGeom>
-          <a:solidFill>
-            <a:srgbClr val="B466FF"/>
-          </a:solidFill>
-          <a:ln>
-            <a:noFill/>
-          </a:ln>
-        </p:spPr>
-        <p:style>
-          <a:lnRef idx="1">
-            <a:schemeClr val="accent1"/>
-          </a:lnRef>
-          <a:fillRef idx="3">
-            <a:schemeClr val="accent1"/>
-          </a:fillRef>
-          <a:effectRef idx="2">
-            <a:schemeClr val="accent1"/>
-          </a:effectRef>
-          <a:fontRef idx="minor">
-            <a:schemeClr val="lt1"/>
-          </a:fontRef>
-        </p:style>
-        <p:txBody>
-          <a:bodyPr rtlCol="0" anchor="ctr"/>
-          <a:lstStyle/>
-          <a:p>
-            <a:pPr algn="ctr"/>
-          </a:p>
-        </p:txBody>
-      </p:sp>
-      <p:sp>
-        <p:nvSpPr>
-          <p:cNvPr id="18" name="TextBox 17"/>
-          <p:cNvSpPr txBox="1"/>
-          <p:nvPr/>
-        </p:nvSpPr>
-        <p:spPr>
-          <a:xfrm>
-            <a:off x="7187184" y="3383280"/>
-            <a:ext cx="2121408" cy="292608"/>
-          </a:xfrm>
-          <a:prstGeom prst="rect">
-            <a:avLst/>
-          </a:prstGeom>
-          <a:noFill/>
-        </p:spPr>
-        <p:txBody>
-          <a:bodyPr wrap="square" lIns="0" rIns="0" tIns="0" bIns="0" anchor="t">
-            <a:spAutoFit/>
-          </a:bodyPr>
-          <a:lstStyle/>
-          <a:p>
-            <a:pPr algn="l"/>
-            <a:r>
-              <a:rPr sz="1200" b="1" i="0">
-                <a:solidFill>
-                  <a:srgbClr val="B466FF"/>
-                </a:solidFill>
-                <a:latin typeface="JetBrains Mono"/>
-              </a:rPr>
-              <a:t>04 / </a:t>
-            </a:r>
-            <a:r>
-              <a:rPr sz="1200" b="1" i="0" spc="150">
-                <a:solidFill>
-                  <a:srgbClr val="B466FF"/>
-                </a:solidFill>
-                <a:latin typeface="JetBrains Mono"/>
-              </a:rPr>
-              <a:t>PRECISION</a:t>
-            </a:r>
-          </a:p>
-        </p:txBody>
-      </p:sp>
-      <p:sp>
-        <p:nvSpPr>
-          <p:cNvPr id="19" name="TextBox 18"/>
-          <p:cNvSpPr txBox="1"/>
-          <p:nvPr/>
-        </p:nvSpPr>
-        <p:spPr>
-          <a:xfrm>
-            <a:off x="7187184" y="3749040"/>
-            <a:ext cx="2121408" cy="1828800"/>
-          </a:xfrm>
-          <a:prstGeom prst="rect">
-            <a:avLst/>
-          </a:prstGeom>
-          <a:noFill/>
-        </p:spPr>
-        <p:txBody>
-          <a:bodyPr wrap="square" lIns="0" rIns="0" tIns="0" bIns="0" anchor="t">
-            <a:spAutoFit/>
-          </a:bodyPr>
-          <a:lstStyle/>
-          <a:p>
-            <a:pPr algn="l"/>
-            <a:r>
-              <a:rPr sz="1150" b="0" i="0">
-                <a:solidFill>
-                  <a:srgbClr val="8A96AA"/>
-                </a:solidFill>
-                <a:latin typeface="Space Grotesk"/>
-              </a:rPr>
-              <a:t>Highest per-token focus. Moderate trajectory spread.</a:t>
-            </a:r>
-          </a:p>
-        </p:txBody>
-      </p:sp>
-      <p:sp>
-        <p:nvSpPr>
-          <p:cNvPr id="20" name="Rectangle 19"/>
-          <p:cNvSpPr/>
-          <p:nvPr/>
-        </p:nvSpPr>
-        <p:spPr>
-          <a:xfrm>
-            <a:off x="9400032" y="3291840"/>
-            <a:ext cx="2121408" cy="27432"/>
-          </a:xfrm>
-          <a:prstGeom prst="rect">
-            <a:avLst/>
-          </a:prstGeom>
-          <a:solidFill>
-            <a:srgbClr val="5A6478"/>
-          </a:solidFill>
-          <a:ln>
-            <a:noFill/>
-          </a:ln>
-        </p:spPr>
-        <p:style>
-          <a:lnRef idx="1">
-            <a:schemeClr val="accent1"/>
-          </a:lnRef>
-          <a:fillRef idx="3">
-            <a:schemeClr val="accent1"/>
-          </a:fillRef>
-          <a:effectRef idx="2">
-            <a:schemeClr val="accent1"/>
-          </a:effectRef>
-          <a:fontRef idx="minor">
-            <a:schemeClr val="lt1"/>
-          </a:fontRef>
-        </p:style>
-        <p:txBody>
-          <a:bodyPr rtlCol="0" anchor="ctr"/>
-          <a:lstStyle/>
-          <a:p>
-            <a:pPr algn="ctr"/>
-          </a:p>
-        </p:txBody>
-      </p:sp>
-      <p:sp>
-        <p:nvSpPr>
-          <p:cNvPr id="21" name="TextBox 20"/>
+          <p:cNvPr id="45" name="TextBox 44"/>
           <p:cNvSpPr txBox="1"/>
           <p:nvPr/>
         </p:nvSpPr>
@@ -9564,7 +10615,7 @@
             <a:r>
               <a:rPr sz="1200" b="1" i="0">
                 <a:solidFill>
-                  <a:srgbClr val="5A6478"/>
+                  <a:srgbClr val="FF9C52"/>
                 </a:solidFill>
                 <a:latin typeface="JetBrains Mono"/>
               </a:rPr>
@@ -9573,7 +10624,7 @@
             <a:r>
               <a:rPr sz="1200" b="1" i="0" spc="150">
                 <a:solidFill>
-                  <a:srgbClr val="5A6478"/>
+                  <a:srgbClr val="FF9C52"/>
                 </a:solidFill>
                 <a:latin typeface="JetBrains Mono"/>
               </a:rPr>
@@ -9584,7 +10635,7 @@
       </p:sp>
       <p:sp>
         <p:nvSpPr>
-          <p:cNvPr id="22" name="TextBox 21"/>
+          <p:cNvPr id="46" name="TextBox 45"/>
           <p:cNvSpPr txBox="1"/>
           <p:nvPr/>
         </p:nvSpPr>
@@ -9619,7 +10670,7 @@
       </p:sp>
       <p:sp>
         <p:nvSpPr>
-          <p:cNvPr id="23" name="TextBox 22"/>
+          <p:cNvPr id="47" name="TextBox 46"/>
           <p:cNvSpPr txBox="1"/>
           <p:nvPr/>
         </p:nvSpPr>

</xml_diff>